<commit_message>
Finalize Assignment 5 presentation and remove redundant PDF
</commit_message>
<xml_diff>
--- a/docs/presentations/assignment-05-internal-server-architecture.pptx
+++ b/docs/presentations/assignment-05-internal-server-architecture.pptx
@@ -4457,55 +4457,34 @@
           <a:noFill/>
         </p:spPr>
         <p:txBody>
-          <a:bodyPr wrap="square" lIns="18288" tIns="13716" rIns="18288">
+          <a:bodyPr wrap="none" lIns="38100" tIns="13716" rIns="25400">
             <a:spAutoFit/>
           </a:bodyPr>
           <a:lstStyle/>
           <a:p>
             <a:pPr>
-              <a:spcAft>
-                <a:spcPts val="300"/>
-              </a:spcAft>
-              <a:defRPr sz="1100" b="0">
-                <a:solidFill>
-                  <a:srgbClr val="686F78"/>
-                </a:solidFill>
-                <a:latin typeface="Aptos"/>
-              </a:defRPr>
-            </a:pPr>
-            <a:r>
+              <a:defRPr sz="1030"/>
+            </a:pPr>
+            <a:r>
+              <a:rPr sz="1030"/>
               <a:t>+ findStudentById(id)</a:t>
             </a:r>
           </a:p>
           <a:p>
             <a:pPr>
-              <a:spcAft>
-                <a:spcPts val="300"/>
-              </a:spcAft>
-              <a:defRPr sz="1100" b="0">
-                <a:solidFill>
-                  <a:srgbClr val="686F78"/>
-                </a:solidFill>
-                <a:latin typeface="Aptos"/>
-              </a:defRPr>
-            </a:pPr>
-            <a:r>
+              <a:defRPr sz="1030"/>
+            </a:pPr>
+            <a:r>
+              <a:rPr sz="1030"/>
               <a:t>+ findProgramsByNames(names)</a:t>
             </a:r>
           </a:p>
           <a:p>
             <a:pPr>
-              <a:spcAft>
-                <a:spcPts val="300"/>
-              </a:spcAft>
-              <a:defRPr sz="1100" b="0">
-                <a:solidFill>
-                  <a:srgbClr val="686F78"/>
-                </a:solidFill>
-                <a:latin typeface="Aptos"/>
-              </a:defRPr>
-            </a:pPr>
-            <a:r>
+              <a:defRPr sz="1030"/>
+            </a:pPr>
+            <a:r>
+              <a:rPr sz="1030"/>
               <a:t>+ findAllPrograms()</a:t>
             </a:r>
           </a:p>
@@ -6243,7 +6222,7 @@
               </a:defRPr>
             </a:pPr>
             <a:r>
-              <a:t>FR-3  Student Information Card</a:t>
+              <a:t>FR-3  Student Info Card</a:t>
             </a:r>
           </a:p>
         </p:txBody>
@@ -6274,7 +6253,7 @@
               <a:spcAft>
                 <a:spcPts val="300"/>
               </a:spcAft>
-              <a:defRPr sz="1100" b="0">
+              <a:defRPr sz="1200" b="0">
                 <a:solidFill>
                   <a:srgbClr val="2B3037"/>
                 </a:solidFill>
@@ -6282,6 +6261,7 @@
               </a:defRPr>
             </a:pPr>
             <a:r>
+              <a:rPr sz="1200"/>
               <a:t>GET /api/students/demo/profile</a:t>
             </a:r>
           </a:p>
@@ -6313,7 +6293,7 @@
               <a:spcAft>
                 <a:spcPts val="300"/>
               </a:spcAft>
-              <a:defRPr sz="1200" b="1">
+              <a:defRPr sz="1300" b="1">
                 <a:solidFill>
                   <a:srgbClr val="2B3037"/>
                 </a:solidFill>
@@ -6321,7 +6301,7 @@
               </a:defRPr>
             </a:pPr>
             <a:r>
-              <a:t>Route  →  StudentController  →  StudentService  →  StudentRepository  →  DemoData</a:t>
+              <a:t>Route → Controller → Service → Repository → DemoData</a:t>
             </a:r>
           </a:p>
         </p:txBody>
@@ -6444,6 +6424,7 @@
               </a:defRPr>
             </a:pPr>
             <a:r>
+              <a:rPr sz="1600"/>
               <a:t>FR-1  Progress Overview</a:t>
             </a:r>
           </a:p>
@@ -6475,7 +6456,7 @@
               <a:spcAft>
                 <a:spcPts val="300"/>
               </a:spcAft>
-              <a:defRPr sz="1100" b="0">
+              <a:defRPr sz="1200" b="0">
                 <a:solidFill>
                   <a:srgbClr val="2B3037"/>
                 </a:solidFill>
@@ -6483,6 +6464,7 @@
               </a:defRPr>
             </a:pPr>
             <a:r>
+              <a:rPr sz="1200"/>
               <a:t>GET /api/students/demo/progress</a:t>
             </a:r>
           </a:p>
@@ -6514,7 +6496,7 @@
               <a:spcAft>
                 <a:spcPts val="300"/>
               </a:spcAft>
-              <a:defRPr sz="1200" b="1">
+              <a:defRPr sz="1300" b="1">
                 <a:solidFill>
                   <a:srgbClr val="2B3037"/>
                 </a:solidFill>
@@ -6522,7 +6504,7 @@
               </a:defRPr>
             </a:pPr>
             <a:r>
-              <a:t>Route  →  StudentController  →  StudentService  →  StudentRepository  →  DemoData</a:t>
+              <a:t>Route → Controller → Service → Repository → DemoData</a:t>
             </a:r>
           </a:p>
         </p:txBody>
@@ -6645,6 +6627,7 @@
               </a:defRPr>
             </a:pPr>
             <a:r>
+              <a:rPr sz="1600"/>
               <a:t>FR-2  Opportunity Finder</a:t>
             </a:r>
           </a:p>
@@ -6676,7 +6659,7 @@
               <a:spcAft>
                 <a:spcPts val="300"/>
               </a:spcAft>
-              <a:defRPr sz="1100" b="0">
+              <a:defRPr sz="1200" b="0">
                 <a:solidFill>
                   <a:srgbClr val="2B3037"/>
                 </a:solidFill>
@@ -6684,6 +6667,7 @@
               </a:defRPr>
             </a:pPr>
             <a:r>
+              <a:rPr sz="1200"/>
               <a:t>GET /api/students/demo/opportunities</a:t>
             </a:r>
           </a:p>
@@ -6715,7 +6699,7 @@
               <a:spcAft>
                 <a:spcPts val="300"/>
               </a:spcAft>
-              <a:defRPr sz="1200" b="1">
+              <a:defRPr sz="1300" b="1">
                 <a:solidFill>
                   <a:srgbClr val="2B3037"/>
                 </a:solidFill>
@@ -6723,7 +6707,7 @@
               </a:defRPr>
             </a:pPr>
             <a:r>
-              <a:t>Route  →  StudentController  →  StudentService  →  StudentRepository  →  DemoData</a:t>
+              <a:t>Route → Controller → Service → Repository → DemoData</a:t>
             </a:r>
           </a:p>
         </p:txBody>

</xml_diff>

<commit_message>
Update Assignment 5 slides with presentation tier
</commit_message>
<xml_diff>
--- a/docs/presentations/assignment-05-internal-server-architecture.pptx
+++ b/docs/presentations/assignment-05-internal-server-architecture.pptx
@@ -4927,24 +4927,14 @@
           <a:noFill/>
         </p:spPr>
         <p:txBody>
-          <a:bodyPr wrap="square" lIns="18288" tIns="13716" rIns="18288">
+          <a:bodyPr wrap="none" lIns="18288" tIns="13716" rIns="18288">
             <a:spAutoFit/>
           </a:bodyPr>
           <a:lstStyle/>
           <a:p>
-            <a:pPr>
-              <a:spcAft>
-                <a:spcPts val="300"/>
-              </a:spcAft>
-              <a:defRPr sz="1200" b="0">
-                <a:solidFill>
-                  <a:srgbClr val="686F78"/>
-                </a:solidFill>
-                <a:latin typeface="Aptos"/>
-              </a:defRPr>
-            </a:pPr>
-            <a:r>
-              <a:t>Verified in GitHub main  •  layered backend merged and documented</a:t>
+            <a:r>
+              <a:rPr sz="1300"/>
+              <a:t>Presentation tier: frontend/UI/ (browser)  •  Server: Layered Architecture  •  API connection pending</a:t>
             </a:r>
           </a:p>
         </p:txBody>
@@ -5139,210 +5129,80 @@
           </a:bodyPr>
           <a:lstStyle/>
           <a:p>
-            <a:pPr>
-              <a:spcAft>
-                <a:spcPts val="300"/>
-              </a:spcAft>
-              <a:defRPr sz="1400" b="0">
-                <a:solidFill>
-                  <a:srgbClr val="2B3037"/>
-                </a:solidFill>
-                <a:latin typeface="Aptos Mono"/>
-              </a:defRPr>
-            </a:pPr>
-            <a:r>
+            <a:r>
+              <a:rPr sz="1400"/>
               <a:t>pathfinder/</a:t>
             </a:r>
           </a:p>
           <a:p>
-            <a:pPr>
-              <a:spcAft>
-                <a:spcPts val="300"/>
-              </a:spcAft>
-              <a:defRPr sz="1400" b="0">
-                <a:solidFill>
-                  <a:srgbClr val="2B3037"/>
-                </a:solidFill>
-                <a:latin typeface="Aptos Mono"/>
-              </a:defRPr>
-            </a:pPr>
-            <a:r>
-              <a:t>├── frontend/UI/              existing browser prototype</a:t>
-            </a:r>
-          </a:p>
-          <a:p>
-            <a:pPr>
-              <a:spcAft>
-                <a:spcPts val="300"/>
-              </a:spcAft>
-              <a:defRPr sz="1400" b="0">
-                <a:solidFill>
-                  <a:srgbClr val="2B3037"/>
-                </a:solidFill>
-                <a:latin typeface="Aptos Mono"/>
-              </a:defRPr>
-            </a:pPr>
-            <a:r>
+            <a:r>
+              <a:rPr sz="1400"/>
+              <a:t>├── frontend/UI/              presentation tier (browser UI)</a:t>
+            </a:r>
+          </a:p>
+          <a:p>
+            <a:r>
+              <a:rPr sz="1400"/>
               <a:t>└── backend/</a:t>
             </a:r>
           </a:p>
           <a:p>
-            <a:pPr>
-              <a:spcAft>
-                <a:spcPts val="300"/>
-              </a:spcAft>
-              <a:defRPr sz="1400" b="0">
-                <a:solidFill>
-                  <a:srgbClr val="2B3037"/>
-                </a:solidFill>
-                <a:latin typeface="Aptos Mono"/>
-              </a:defRPr>
-            </a:pPr>
-            <a:r>
+            <a:r>
+              <a:rPr sz="1400"/>
               <a:t>    ├── app.js                 Express entry point</a:t>
             </a:r>
           </a:p>
           <a:p>
-            <a:pPr>
-              <a:spcAft>
-                <a:spcPts val="300"/>
-              </a:spcAft>
-              <a:defRPr sz="1400" b="0">
-                <a:solidFill>
-                  <a:srgbClr val="2B3037"/>
-                </a:solidFill>
-                <a:latin typeface="Aptos Mono"/>
-              </a:defRPr>
-            </a:pPr>
-            <a:r>
+            <a:r>
+              <a:rPr sz="1400"/>
               <a:t>    ├── routes/students.js</a:t>
             </a:r>
           </a:p>
           <a:p>
-            <a:pPr>
-              <a:spcAft>
-                <a:spcPts val="300"/>
-              </a:spcAft>
-              <a:defRPr sz="1400" b="0">
-                <a:solidFill>
-                  <a:srgbClr val="2B3037"/>
-                </a:solidFill>
-                <a:latin typeface="Aptos Mono"/>
-              </a:defRPr>
-            </a:pPr>
-            <a:r>
+            <a:r>
+              <a:rPr sz="1400"/>
               <a:t>    ├── controllers/studentController.js</a:t>
             </a:r>
           </a:p>
           <a:p>
-            <a:pPr>
-              <a:spcAft>
-                <a:spcPts val="300"/>
-              </a:spcAft>
-              <a:defRPr sz="1400" b="0">
-                <a:solidFill>
-                  <a:srgbClr val="2B3037"/>
-                </a:solidFill>
-                <a:latin typeface="Aptos Mono"/>
-              </a:defRPr>
-            </a:pPr>
-            <a:r>
+            <a:r>
+              <a:rPr sz="1400"/>
               <a:t>    ├── services/studentService.js</a:t>
             </a:r>
           </a:p>
           <a:p>
-            <a:pPr>
-              <a:spcAft>
-                <a:spcPts val="300"/>
-              </a:spcAft>
-              <a:defRPr sz="1400" b="0">
-                <a:solidFill>
-                  <a:srgbClr val="2B3037"/>
-                </a:solidFill>
-                <a:latin typeface="Aptos Mono"/>
-              </a:defRPr>
-            </a:pPr>
-            <a:r>
+            <a:r>
+              <a:rPr sz="1400"/>
               <a:t>    ├── repositories/studentRepository.js</a:t>
             </a:r>
           </a:p>
           <a:p>
-            <a:pPr>
-              <a:spcAft>
-                <a:spcPts val="300"/>
-              </a:spcAft>
-              <a:defRPr sz="1400" b="0">
-                <a:solidFill>
-                  <a:srgbClr val="2B3037"/>
-                </a:solidFill>
-                <a:latin typeface="Aptos Mono"/>
-              </a:defRPr>
-            </a:pPr>
-            <a:r>
+            <a:r>
+              <a:rPr sz="1400"/>
               <a:t>    ├── data/demoData.js</a:t>
             </a:r>
           </a:p>
           <a:p>
-            <a:pPr>
-              <a:spcAft>
-                <a:spcPts val="300"/>
-              </a:spcAft>
-              <a:defRPr sz="1400" b="0">
-                <a:solidFill>
-                  <a:srgbClr val="2B3037"/>
-                </a:solidFill>
-                <a:latin typeface="Aptos Mono"/>
-              </a:defRPr>
-            </a:pPr>
-            <a:r>
+            <a:r>
+              <a:rPr sz="1400"/>
               <a:t>    ├── package.json</a:t>
             </a:r>
           </a:p>
           <a:p>
-            <a:pPr>
-              <a:spcAft>
-                <a:spcPts val="300"/>
-              </a:spcAft>
-              <a:defRPr sz="1400" b="0">
-                <a:solidFill>
-                  <a:srgbClr val="2B3037"/>
-                </a:solidFill>
-                <a:latin typeface="Aptos Mono"/>
-              </a:defRPr>
-            </a:pPr>
-            <a:r>
+            <a:r>
+              <a:rPr sz="1400"/>
               <a:t>    └── package-lock.json</a:t>
             </a:r>
           </a:p>
           <a:p>
-            <a:pPr>
-              <a:spcAft>
-                <a:spcPts val="300"/>
-              </a:spcAft>
-              <a:defRPr sz="1400" b="0">
-                <a:solidFill>
-                  <a:srgbClr val="2B3037"/>
-                </a:solidFill>
-                <a:latin typeface="Aptos Mono"/>
-              </a:defRPr>
-            </a:pPr>
-            <a:r>
+            <a:r>
+              <a:rPr sz="1400"/>
               <a:t>tests/backend.test.js</a:t>
             </a:r>
           </a:p>
           <a:p>
-            <a:pPr>
-              <a:spcAft>
-                <a:spcPts val="300"/>
-              </a:spcAft>
-              <a:defRPr sz="1400" b="0">
-                <a:solidFill>
-                  <a:srgbClr val="2B3037"/>
-                </a:solidFill>
-                <a:latin typeface="Aptos Mono"/>
-              </a:defRPr>
-            </a:pPr>
-            <a:r>
+            <a:r>
+              <a:rPr sz="1400"/>
               <a:t>docs/diagrams/assignment-05-class-diagram.md</a:t>
             </a:r>
           </a:p>

</xml_diff>

<commit_message>
Clarify planned HAL chatbot integration in Assignment 5
</commit_message>
<xml_diff>
--- a/docs/presentations/assignment-05-internal-server-architecture.pptx
+++ b/docs/presentations/assignment-05-internal-server-architecture.pptx
@@ -5700,6 +5700,42 @@
           </a:p>
         </p:txBody>
       </p:sp>
+      <p:sp>
+        <p:nvSpPr>
+          <p:cNvPr id="23" name="TextBox 22"/>
+          <p:cNvSpPr txBox="1"/>
+          <p:nvPr/>
+        </p:nvSpPr>
+        <p:spPr>
+          <a:xfrm>
+            <a:off x="685800" y="6163056"/>
+            <a:ext cx="10972800" cy="201168"/>
+          </a:xfrm>
+          <a:prstGeom prst="rect">
+            <a:avLst/>
+          </a:prstGeom>
+          <a:noFill/>
+        </p:spPr>
+        <p:txBody>
+          <a:bodyPr wrap="none" lIns="0" rIns="0" tIns="0" bIns="0">
+            <a:spAutoFit/>
+          </a:bodyPr>
+          <a:lstStyle/>
+          <a:p>
+            <a:pPr>
+              <a:defRPr sz="1000" b="0">
+                <a:solidFill>
+                  <a:srgbClr val="9F1A2E"/>
+                </a:solidFill>
+                <a:latin typeface="Aptos"/>
+              </a:defRPr>
+            </a:pPr>
+            <a:r>
+              <a:t>HAL (FR-4): chat interface is part of the frontend; the chat API, AI integration and backend modules are planned.</a:t>
+            </a:r>
+          </a:p>
+        </p:txBody>
+      </p:sp>
     </p:spTree>
   </p:cSld>
   <p:clrMapOvr>
@@ -6619,8 +6655,8 @@
         </p:nvSpPr>
         <p:spPr>
           <a:xfrm>
-            <a:off x="768096" y="5998464"/>
-            <a:ext cx="10881360" cy="256032"/>
+            <a:off x="768096" y="6199632"/>
+            <a:ext cx="10881360" cy="182880"/>
           </a:xfrm>
           <a:prstGeom prst="rect">
             <a:avLst/>
@@ -6645,7 +6681,44 @@
               </a:defRPr>
             </a:pPr>
             <a:r>
+              <a:rPr sz="900"/>
               <a:t>Current scope: JSON API prototype, not yet integrated with the frontend, authentication, or a production database.</a:t>
+            </a:r>
+          </a:p>
+        </p:txBody>
+      </p:sp>
+      <p:sp>
+        <p:nvSpPr>
+          <p:cNvPr id="25" name="TextBox 24"/>
+          <p:cNvSpPr txBox="1"/>
+          <p:nvPr/>
+        </p:nvSpPr>
+        <p:spPr>
+          <a:xfrm>
+            <a:off x="768096" y="5843016"/>
+            <a:ext cx="10698480" cy="256032"/>
+          </a:xfrm>
+          <a:prstGeom prst="rect">
+            <a:avLst/>
+          </a:prstGeom>
+          <a:noFill/>
+        </p:spPr>
+        <p:txBody>
+          <a:bodyPr wrap="none" lIns="0" rIns="0" tIns="0" bIns="0">
+            <a:spAutoFit/>
+          </a:bodyPr>
+          <a:lstStyle/>
+          <a:p>
+            <a:pPr>
+              <a:defRPr sz="1100" b="1">
+                <a:solidFill>
+                  <a:srgbClr val="9F1A2E"/>
+                </a:solidFill>
+                <a:latin typeface="Aptos"/>
+              </a:defRPr>
+            </a:pPr>
+            <a:r>
+              <a:t>FR-4 HAL AI Chatbot — PLANNED: chat UI → chat controller/service → academic context + external AI API</a:t>
             </a:r>
           </a:p>
         </p:txBody>

</xml_diff>

<commit_message>
Update Assignment 5 presentation with final revisions
</commit_message>
<xml_diff>
--- a/docs/presentations/assignment-05-internal-server-architecture.pptx
+++ b/docs/presentations/assignment-05-internal-server-architecture.pptx
@@ -5,11 +5,11 @@
     <p:sldMasterId id="2147483648" r:id="rId1"/>
   </p:sldMasterIdLst>
   <p:sldIdLst>
-    <p:sldId id="256" r:id="rId7"/>
-    <p:sldId id="257" r:id="rId8"/>
-    <p:sldId id="258" r:id="rId9"/>
+    <p:sldId id="256" r:id="rId2"/>
+    <p:sldId id="257" r:id="rId3"/>
+    <p:sldId id="258" r:id="rId4"/>
   </p:sldIdLst>
-  <p:sldSz cx="12191695" cy="6858000" type="screen4x3"/>
+  <p:sldSz cx="12192000" cy="6858000"/>
   <p:notesSz cx="6858000" cy="9144000"/>
   <p:defaultTextStyle>
     <a:defPPr>
@@ -106,6 +106,22 @@
       </a:defRPr>
     </a:lvl9pPr>
   </p:defaultTextStyle>
+  <p:extLst>
+    <p:ext uri="{EFAFB233-063F-42B5-8137-9DF3F51BA10A}">
+      <p15:sldGuideLst xmlns:p15="http://schemas.microsoft.com/office/powerpoint/2012/main">
+        <p15:guide id="1" orient="horz" pos="2160">
+          <p15:clr>
+            <a:srgbClr val="A4A3A4"/>
+          </p15:clr>
+        </p15:guide>
+        <p15:guide id="2" pos="2880">
+          <p15:clr>
+            <a:srgbClr val="A4A3A4"/>
+          </p15:clr>
+        </p15:guide>
+      </p15:sldGuideLst>
+    </p:ext>
+  </p:extLst>
 </p:presentation>
 </file>
 
@@ -147,10 +163,9 @@
           <a:lstStyle/>
           <a:p>
             <a:r>
-              <a:rPr lang="en-US" smtClean="0"/>
+              <a:rPr lang="en-US"/>
               <a:t>Click to edit Master title style</a:t>
             </a:r>
-            <a:endParaRPr lang="en-US"/>
           </a:p>
         </p:txBody>
       </p:sp>
@@ -266,10 +281,9 @@
           </a:lstStyle>
           <a:p>
             <a:r>
-              <a:rPr lang="en-US" smtClean="0"/>
+              <a:rPr lang="en-US"/>
               <a:t>Click to edit Master subtitle style</a:t>
             </a:r>
-            <a:endParaRPr lang="en-US"/>
           </a:p>
         </p:txBody>
       </p:sp>
@@ -290,7 +304,7 @@
           <a:p>
             <a:fld id="{5BCAD085-E8A6-8845-BD4E-CB4CCA059FC4}" type="datetimeFigureOut">
               <a:rPr lang="en-US" smtClean="0"/>
-              <a:t>1/27/13</a:t>
+              <a:t>10/28/26</a:t>
             </a:fld>
             <a:endParaRPr lang="en-US"/>
           </a:p>
@@ -384,10 +398,9 @@
           <a:lstStyle/>
           <a:p>
             <a:r>
-              <a:rPr lang="en-US" smtClean="0"/>
+              <a:rPr lang="en-US"/>
               <a:t>Click to edit Master title style</a:t>
             </a:r>
-            <a:endParaRPr lang="en-US"/>
           </a:p>
         </p:txBody>
       </p:sp>
@@ -408,38 +421,37 @@
           <a:p>
             <a:pPr lvl="0"/>
             <a:r>
-              <a:rPr lang="en-US" smtClean="0"/>
+              <a:rPr lang="en-US"/>
               <a:t>Click to edit Master text styles</a:t>
             </a:r>
           </a:p>
           <a:p>
             <a:pPr lvl="1"/>
             <a:r>
-              <a:rPr lang="en-US" smtClean="0"/>
+              <a:rPr lang="en-US"/>
               <a:t>Second level</a:t>
             </a:r>
           </a:p>
           <a:p>
             <a:pPr lvl="2"/>
             <a:r>
-              <a:rPr lang="en-US" smtClean="0"/>
+              <a:rPr lang="en-US"/>
               <a:t>Third level</a:t>
             </a:r>
           </a:p>
           <a:p>
             <a:pPr lvl="3"/>
             <a:r>
-              <a:rPr lang="en-US" smtClean="0"/>
+              <a:rPr lang="en-US"/>
               <a:t>Fourth level</a:t>
             </a:r>
           </a:p>
           <a:p>
             <a:pPr lvl="4"/>
             <a:r>
-              <a:rPr lang="en-US" smtClean="0"/>
+              <a:rPr lang="en-US"/>
               <a:t>Fifth level</a:t>
             </a:r>
-            <a:endParaRPr lang="en-US"/>
           </a:p>
         </p:txBody>
       </p:sp>
@@ -460,7 +472,7 @@
           <a:p>
             <a:fld id="{5BCAD085-E8A6-8845-BD4E-CB4CCA059FC4}" type="datetimeFigureOut">
               <a:rPr lang="en-US" smtClean="0"/>
-              <a:t>1/27/13</a:t>
+              <a:t>10/28/26</a:t>
             </a:fld>
             <a:endParaRPr lang="en-US"/>
           </a:p>
@@ -559,10 +571,9 @@
           <a:lstStyle/>
           <a:p>
             <a:r>
-              <a:rPr lang="en-US" smtClean="0"/>
+              <a:rPr lang="en-US"/>
               <a:t>Click to edit Master title style</a:t>
             </a:r>
-            <a:endParaRPr lang="en-US"/>
           </a:p>
         </p:txBody>
       </p:sp>
@@ -588,38 +599,37 @@
           <a:p>
             <a:pPr lvl="0"/>
             <a:r>
-              <a:rPr lang="en-US" smtClean="0"/>
+              <a:rPr lang="en-US"/>
               <a:t>Click to edit Master text styles</a:t>
             </a:r>
           </a:p>
           <a:p>
             <a:pPr lvl="1"/>
             <a:r>
-              <a:rPr lang="en-US" smtClean="0"/>
+              <a:rPr lang="en-US"/>
               <a:t>Second level</a:t>
             </a:r>
           </a:p>
           <a:p>
             <a:pPr lvl="2"/>
             <a:r>
-              <a:rPr lang="en-US" smtClean="0"/>
+              <a:rPr lang="en-US"/>
               <a:t>Third level</a:t>
             </a:r>
           </a:p>
           <a:p>
             <a:pPr lvl="3"/>
             <a:r>
-              <a:rPr lang="en-US" smtClean="0"/>
+              <a:rPr lang="en-US"/>
               <a:t>Fourth level</a:t>
             </a:r>
           </a:p>
           <a:p>
             <a:pPr lvl="4"/>
             <a:r>
-              <a:rPr lang="en-US" smtClean="0"/>
+              <a:rPr lang="en-US"/>
               <a:t>Fifth level</a:t>
             </a:r>
-            <a:endParaRPr lang="en-US"/>
           </a:p>
         </p:txBody>
       </p:sp>
@@ -640,7 +650,7 @@
           <a:p>
             <a:fld id="{5BCAD085-E8A6-8845-BD4E-CB4CCA059FC4}" type="datetimeFigureOut">
               <a:rPr lang="en-US" smtClean="0"/>
-              <a:t>1/27/13</a:t>
+              <a:t>10/28/26</a:t>
             </a:fld>
             <a:endParaRPr lang="en-US"/>
           </a:p>
@@ -734,10 +744,9 @@
           <a:lstStyle/>
           <a:p>
             <a:r>
-              <a:rPr lang="en-US" smtClean="0"/>
+              <a:rPr lang="en-US"/>
               <a:t>Click to edit Master title style</a:t>
             </a:r>
-            <a:endParaRPr lang="en-US"/>
           </a:p>
         </p:txBody>
       </p:sp>
@@ -758,38 +767,37 @@
           <a:p>
             <a:pPr lvl="0"/>
             <a:r>
-              <a:rPr lang="en-US" smtClean="0"/>
+              <a:rPr lang="en-US"/>
               <a:t>Click to edit Master text styles</a:t>
             </a:r>
           </a:p>
           <a:p>
             <a:pPr lvl="1"/>
             <a:r>
-              <a:rPr lang="en-US" smtClean="0"/>
+              <a:rPr lang="en-US"/>
               <a:t>Second level</a:t>
             </a:r>
           </a:p>
           <a:p>
             <a:pPr lvl="2"/>
             <a:r>
-              <a:rPr lang="en-US" smtClean="0"/>
+              <a:rPr lang="en-US"/>
               <a:t>Third level</a:t>
             </a:r>
           </a:p>
           <a:p>
             <a:pPr lvl="3"/>
             <a:r>
-              <a:rPr lang="en-US" smtClean="0"/>
+              <a:rPr lang="en-US"/>
               <a:t>Fourth level</a:t>
             </a:r>
           </a:p>
           <a:p>
             <a:pPr lvl="4"/>
             <a:r>
-              <a:rPr lang="en-US" smtClean="0"/>
+              <a:rPr lang="en-US"/>
               <a:t>Fifth level</a:t>
             </a:r>
-            <a:endParaRPr lang="en-US"/>
           </a:p>
         </p:txBody>
       </p:sp>
@@ -810,7 +818,7 @@
           <a:p>
             <a:fld id="{5BCAD085-E8A6-8845-BD4E-CB4CCA059FC4}" type="datetimeFigureOut">
               <a:rPr lang="en-US" smtClean="0"/>
-              <a:t>1/27/13</a:t>
+              <a:t>10/28/26</a:t>
             </a:fld>
             <a:endParaRPr lang="en-US"/>
           </a:p>
@@ -913,10 +921,9 @@
           </a:lstStyle>
           <a:p>
             <a:r>
-              <a:rPr lang="en-US" smtClean="0"/>
+              <a:rPr lang="en-US"/>
               <a:t>Click to edit Master title style</a:t>
             </a:r>
-            <a:endParaRPr lang="en-US"/>
           </a:p>
         </p:txBody>
       </p:sp>
@@ -1033,7 +1040,7 @@
           <a:p>
             <a:pPr lvl="0"/>
             <a:r>
-              <a:rPr lang="en-US" smtClean="0"/>
+              <a:rPr lang="en-US"/>
               <a:t>Click to edit Master text styles</a:t>
             </a:r>
           </a:p>
@@ -1056,7 +1063,7 @@
           <a:p>
             <a:fld id="{5BCAD085-E8A6-8845-BD4E-CB4CCA059FC4}" type="datetimeFigureOut">
               <a:rPr lang="en-US" smtClean="0"/>
-              <a:t>1/27/13</a:t>
+              <a:t>10/28/26</a:t>
             </a:fld>
             <a:endParaRPr lang="en-US"/>
           </a:p>
@@ -1150,10 +1157,9 @@
           <a:lstStyle/>
           <a:p>
             <a:r>
-              <a:rPr lang="en-US" smtClean="0"/>
+              <a:rPr lang="en-US"/>
               <a:t>Click to edit Master title style</a:t>
             </a:r>
-            <a:endParaRPr lang="en-US"/>
           </a:p>
         </p:txBody>
       </p:sp>
@@ -1207,38 +1213,37 @@
           <a:p>
             <a:pPr lvl="0"/>
             <a:r>
-              <a:rPr lang="en-US" smtClean="0"/>
+              <a:rPr lang="en-US"/>
               <a:t>Click to edit Master text styles</a:t>
             </a:r>
           </a:p>
           <a:p>
             <a:pPr lvl="1"/>
             <a:r>
-              <a:rPr lang="en-US" smtClean="0"/>
+              <a:rPr lang="en-US"/>
               <a:t>Second level</a:t>
             </a:r>
           </a:p>
           <a:p>
             <a:pPr lvl="2"/>
             <a:r>
-              <a:rPr lang="en-US" smtClean="0"/>
+              <a:rPr lang="en-US"/>
               <a:t>Third level</a:t>
             </a:r>
           </a:p>
           <a:p>
             <a:pPr lvl="3"/>
             <a:r>
-              <a:rPr lang="en-US" smtClean="0"/>
+              <a:rPr lang="en-US"/>
               <a:t>Fourth level</a:t>
             </a:r>
           </a:p>
           <a:p>
             <a:pPr lvl="4"/>
             <a:r>
-              <a:rPr lang="en-US" smtClean="0"/>
+              <a:rPr lang="en-US"/>
               <a:t>Fifth level</a:t>
             </a:r>
-            <a:endParaRPr lang="en-US"/>
           </a:p>
         </p:txBody>
       </p:sp>
@@ -1292,38 +1297,37 @@
           <a:p>
             <a:pPr lvl="0"/>
             <a:r>
-              <a:rPr lang="en-US" smtClean="0"/>
+              <a:rPr lang="en-US"/>
               <a:t>Click to edit Master text styles</a:t>
             </a:r>
           </a:p>
           <a:p>
             <a:pPr lvl="1"/>
             <a:r>
-              <a:rPr lang="en-US" smtClean="0"/>
+              <a:rPr lang="en-US"/>
               <a:t>Second level</a:t>
             </a:r>
           </a:p>
           <a:p>
             <a:pPr lvl="2"/>
             <a:r>
-              <a:rPr lang="en-US" smtClean="0"/>
+              <a:rPr lang="en-US"/>
               <a:t>Third level</a:t>
             </a:r>
           </a:p>
           <a:p>
             <a:pPr lvl="3"/>
             <a:r>
-              <a:rPr lang="en-US" smtClean="0"/>
+              <a:rPr lang="en-US"/>
               <a:t>Fourth level</a:t>
             </a:r>
           </a:p>
           <a:p>
             <a:pPr lvl="4"/>
             <a:r>
-              <a:rPr lang="en-US" smtClean="0"/>
+              <a:rPr lang="en-US"/>
               <a:t>Fifth level</a:t>
             </a:r>
-            <a:endParaRPr lang="en-US"/>
           </a:p>
         </p:txBody>
       </p:sp>
@@ -1344,7 +1348,7 @@
           <a:p>
             <a:fld id="{5BCAD085-E8A6-8845-BD4E-CB4CCA059FC4}" type="datetimeFigureOut">
               <a:rPr lang="en-US" smtClean="0"/>
-              <a:t>1/27/13</a:t>
+              <a:t>10/28/26</a:t>
             </a:fld>
             <a:endParaRPr lang="en-US"/>
           </a:p>
@@ -1442,10 +1446,9 @@
           </a:lstStyle>
           <a:p>
             <a:r>
-              <a:rPr lang="en-US" smtClean="0"/>
+              <a:rPr lang="en-US"/>
               <a:t>Click to edit Master title style</a:t>
             </a:r>
-            <a:endParaRPr lang="en-US"/>
           </a:p>
         </p:txBody>
       </p:sp>
@@ -1508,7 +1511,7 @@
           <a:p>
             <a:pPr lvl="0"/>
             <a:r>
-              <a:rPr lang="en-US" smtClean="0"/>
+              <a:rPr lang="en-US"/>
               <a:t>Click to edit Master text styles</a:t>
             </a:r>
           </a:p>
@@ -1564,38 +1567,37 @@
           <a:p>
             <a:pPr lvl="0"/>
             <a:r>
-              <a:rPr lang="en-US" smtClean="0"/>
+              <a:rPr lang="en-US"/>
               <a:t>Click to edit Master text styles</a:t>
             </a:r>
           </a:p>
           <a:p>
             <a:pPr lvl="1"/>
             <a:r>
-              <a:rPr lang="en-US" smtClean="0"/>
+              <a:rPr lang="en-US"/>
               <a:t>Second level</a:t>
             </a:r>
           </a:p>
           <a:p>
             <a:pPr lvl="2"/>
             <a:r>
-              <a:rPr lang="en-US" smtClean="0"/>
+              <a:rPr lang="en-US"/>
               <a:t>Third level</a:t>
             </a:r>
           </a:p>
           <a:p>
             <a:pPr lvl="3"/>
             <a:r>
-              <a:rPr lang="en-US" smtClean="0"/>
+              <a:rPr lang="en-US"/>
               <a:t>Fourth level</a:t>
             </a:r>
           </a:p>
           <a:p>
             <a:pPr lvl="4"/>
             <a:r>
-              <a:rPr lang="en-US" smtClean="0"/>
+              <a:rPr lang="en-US"/>
               <a:t>Fifth level</a:t>
             </a:r>
-            <a:endParaRPr lang="en-US"/>
           </a:p>
         </p:txBody>
       </p:sp>
@@ -1658,7 +1660,7 @@
           <a:p>
             <a:pPr lvl="0"/>
             <a:r>
-              <a:rPr lang="en-US" smtClean="0"/>
+              <a:rPr lang="en-US"/>
               <a:t>Click to edit Master text styles</a:t>
             </a:r>
           </a:p>
@@ -1714,38 +1716,37 @@
           <a:p>
             <a:pPr lvl="0"/>
             <a:r>
-              <a:rPr lang="en-US" smtClean="0"/>
+              <a:rPr lang="en-US"/>
               <a:t>Click to edit Master text styles</a:t>
             </a:r>
           </a:p>
           <a:p>
             <a:pPr lvl="1"/>
             <a:r>
-              <a:rPr lang="en-US" smtClean="0"/>
+              <a:rPr lang="en-US"/>
               <a:t>Second level</a:t>
             </a:r>
           </a:p>
           <a:p>
             <a:pPr lvl="2"/>
             <a:r>
-              <a:rPr lang="en-US" smtClean="0"/>
+              <a:rPr lang="en-US"/>
               <a:t>Third level</a:t>
             </a:r>
           </a:p>
           <a:p>
             <a:pPr lvl="3"/>
             <a:r>
-              <a:rPr lang="en-US" smtClean="0"/>
+              <a:rPr lang="en-US"/>
               <a:t>Fourth level</a:t>
             </a:r>
           </a:p>
           <a:p>
             <a:pPr lvl="4"/>
             <a:r>
-              <a:rPr lang="en-US" smtClean="0"/>
+              <a:rPr lang="en-US"/>
               <a:t>Fifth level</a:t>
             </a:r>
-            <a:endParaRPr lang="en-US"/>
           </a:p>
         </p:txBody>
       </p:sp>
@@ -1766,7 +1767,7 @@
           <a:p>
             <a:fld id="{5BCAD085-E8A6-8845-BD4E-CB4CCA059FC4}" type="datetimeFigureOut">
               <a:rPr lang="en-US" smtClean="0"/>
-              <a:t>1/27/13</a:t>
+              <a:t>10/28/26</a:t>
             </a:fld>
             <a:endParaRPr lang="en-US"/>
           </a:p>
@@ -1860,10 +1861,9 @@
           <a:lstStyle/>
           <a:p>
             <a:r>
-              <a:rPr lang="en-US" smtClean="0"/>
+              <a:rPr lang="en-US"/>
               <a:t>Click to edit Master title style</a:t>
             </a:r>
-            <a:endParaRPr lang="en-US"/>
           </a:p>
         </p:txBody>
       </p:sp>
@@ -1884,7 +1884,7 @@
           <a:p>
             <a:fld id="{5BCAD085-E8A6-8845-BD4E-CB4CCA059FC4}" type="datetimeFigureOut">
               <a:rPr lang="en-US" smtClean="0"/>
-              <a:t>1/27/13</a:t>
+              <a:t>10/28/26</a:t>
             </a:fld>
             <a:endParaRPr lang="en-US"/>
           </a:p>
@@ -1979,7 +1979,7 @@
           <a:p>
             <a:fld id="{5BCAD085-E8A6-8845-BD4E-CB4CCA059FC4}" type="datetimeFigureOut">
               <a:rPr lang="en-US" smtClean="0"/>
-              <a:t>1/27/13</a:t>
+              <a:t>10/28/26</a:t>
             </a:fld>
             <a:endParaRPr lang="en-US"/>
           </a:p>
@@ -2082,10 +2082,9 @@
           </a:lstStyle>
           <a:p>
             <a:r>
-              <a:rPr lang="en-US" smtClean="0"/>
+              <a:rPr lang="en-US"/>
               <a:t>Click to edit Master title style</a:t>
             </a:r>
-            <a:endParaRPr lang="en-US"/>
           </a:p>
         </p:txBody>
       </p:sp>
@@ -2139,38 +2138,37 @@
           <a:p>
             <a:pPr lvl="0"/>
             <a:r>
-              <a:rPr lang="en-US" smtClean="0"/>
+              <a:rPr lang="en-US"/>
               <a:t>Click to edit Master text styles</a:t>
             </a:r>
           </a:p>
           <a:p>
             <a:pPr lvl="1"/>
             <a:r>
-              <a:rPr lang="en-US" smtClean="0"/>
+              <a:rPr lang="en-US"/>
               <a:t>Second level</a:t>
             </a:r>
           </a:p>
           <a:p>
             <a:pPr lvl="2"/>
             <a:r>
-              <a:rPr lang="en-US" smtClean="0"/>
+              <a:rPr lang="en-US"/>
               <a:t>Third level</a:t>
             </a:r>
           </a:p>
           <a:p>
             <a:pPr lvl="3"/>
             <a:r>
-              <a:rPr lang="en-US" smtClean="0"/>
+              <a:rPr lang="en-US"/>
               <a:t>Fourth level</a:t>
             </a:r>
           </a:p>
           <a:p>
             <a:pPr lvl="4"/>
             <a:r>
-              <a:rPr lang="en-US" smtClean="0"/>
+              <a:rPr lang="en-US"/>
               <a:t>Fifth level</a:t>
             </a:r>
-            <a:endParaRPr lang="en-US"/>
           </a:p>
         </p:txBody>
       </p:sp>
@@ -2233,7 +2231,7 @@
           <a:p>
             <a:pPr lvl="0"/>
             <a:r>
-              <a:rPr lang="en-US" smtClean="0"/>
+              <a:rPr lang="en-US"/>
               <a:t>Click to edit Master text styles</a:t>
             </a:r>
           </a:p>
@@ -2256,7 +2254,7 @@
           <a:p>
             <a:fld id="{5BCAD085-E8A6-8845-BD4E-CB4CCA059FC4}" type="datetimeFigureOut">
               <a:rPr lang="en-US" smtClean="0"/>
-              <a:t>1/27/13</a:t>
+              <a:t>10/28/26</a:t>
             </a:fld>
             <a:endParaRPr lang="en-US"/>
           </a:p>
@@ -2359,10 +2357,9 @@
           </a:lstStyle>
           <a:p>
             <a:r>
-              <a:rPr lang="en-US" smtClean="0"/>
+              <a:rPr lang="en-US"/>
               <a:t>Click to edit Master title style</a:t>
             </a:r>
-            <a:endParaRPr lang="en-US"/>
           </a:p>
         </p:txBody>
       </p:sp>
@@ -2486,7 +2483,7 @@
           <a:p>
             <a:pPr lvl="0"/>
             <a:r>
-              <a:rPr lang="en-US" smtClean="0"/>
+              <a:rPr lang="en-US"/>
               <a:t>Click to edit Master text styles</a:t>
             </a:r>
           </a:p>
@@ -2509,7 +2506,7 @@
           <a:p>
             <a:fld id="{5BCAD085-E8A6-8845-BD4E-CB4CCA059FC4}" type="datetimeFigureOut">
               <a:rPr lang="en-US" smtClean="0"/>
-              <a:t>1/27/13</a:t>
+              <a:t>10/28/26</a:t>
             </a:fld>
             <a:endParaRPr lang="en-US"/>
           </a:p>
@@ -2618,10 +2615,9 @@
           <a:lstStyle/>
           <a:p>
             <a:r>
-              <a:rPr lang="en-US" smtClean="0"/>
+              <a:rPr lang="en-US"/>
               <a:t>Click to edit Master title style</a:t>
             </a:r>
-            <a:endParaRPr lang="en-US"/>
           </a:p>
         </p:txBody>
       </p:sp>
@@ -2652,38 +2648,37 @@
           <a:p>
             <a:pPr lvl="0"/>
             <a:r>
-              <a:rPr lang="en-US" smtClean="0"/>
+              <a:rPr lang="en-US"/>
               <a:t>Click to edit Master text styles</a:t>
             </a:r>
           </a:p>
           <a:p>
             <a:pPr lvl="1"/>
             <a:r>
-              <a:rPr lang="en-US" smtClean="0"/>
+              <a:rPr lang="en-US"/>
               <a:t>Second level</a:t>
             </a:r>
           </a:p>
           <a:p>
             <a:pPr lvl="2"/>
             <a:r>
-              <a:rPr lang="en-US" smtClean="0"/>
+              <a:rPr lang="en-US"/>
               <a:t>Third level</a:t>
             </a:r>
           </a:p>
           <a:p>
             <a:pPr lvl="3"/>
             <a:r>
-              <a:rPr lang="en-US" smtClean="0"/>
+              <a:rPr lang="en-US"/>
               <a:t>Fourth level</a:t>
             </a:r>
           </a:p>
           <a:p>
             <a:pPr lvl="4"/>
             <a:r>
-              <a:rPr lang="en-US" smtClean="0"/>
+              <a:rPr lang="en-US"/>
               <a:t>Fifth level</a:t>
             </a:r>
-            <a:endParaRPr lang="en-US"/>
           </a:p>
         </p:txBody>
       </p:sp>
@@ -2722,7 +2717,7 @@
           <a:p>
             <a:fld id="{5BCAD085-E8A6-8845-BD4E-CB4CCA059FC4}" type="datetimeFigureOut">
               <a:rPr lang="en-US" smtClean="0"/>
-              <a:t>1/27/13</a:t>
+              <a:t>10/28/26</a:t>
             </a:fld>
             <a:endParaRPr lang="en-US"/>
           </a:p>
@@ -3081,7 +3076,7 @@
 </file>
 
 <file path=ppt/slides/slide1.xml><?xml version="1.0" encoding="utf-8"?>
-<p:sld xmlns:a="http://schemas.openxmlformats.org/drawingml/2006/main" xmlns:p="http://schemas.openxmlformats.org/presentationml/2006/main" xmlns:r="http://schemas.openxmlformats.org/officeDocument/2006/relationships">
+<p:sld xmlns:a="http://schemas.openxmlformats.org/drawingml/2006/main" xmlns:r="http://schemas.openxmlformats.org/officeDocument/2006/relationships" xmlns:p="http://schemas.openxmlformats.org/presentationml/2006/main">
   <p:cSld>
     <p:spTree>
       <p:nvGrpSpPr>
@@ -3089,7 +3084,14 @@
         <p:cNvGrpSpPr/>
         <p:nvPr/>
       </p:nvGrpSpPr>
-      <p:grpSpPr/>
+      <p:grpSpPr>
+        <a:xfrm>
+          <a:off x="0" y="0"/>
+          <a:ext cx="0" cy="0"/>
+          <a:chOff x="0" y="0"/>
+          <a:chExt cx="0" cy="0"/>
+        </a:xfrm>
+      </p:grpSpPr>
       <p:sp>
         <p:nvSpPr>
           <p:cNvPr id="2" name="Rectangle 1"/>
@@ -3132,6 +3134,7 @@
           <a:lstStyle/>
           <a:p>
             <a:pPr algn="ctr"/>
+            <a:endParaRPr/>
           </a:p>
         </p:txBody>
       </p:sp>
@@ -3144,7 +3147,7 @@
         <p:spPr>
           <a:xfrm>
             <a:off x="566928" y="274320"/>
-            <a:ext cx="8229600" cy="274320"/>
+            <a:ext cx="8229600" cy="229294"/>
           </a:xfrm>
           <a:prstGeom prst="rect">
             <a:avLst/>
@@ -3169,7 +3172,8 @@
               </a:defRPr>
             </a:pPr>
             <a:r>
-              <a:t>PATHFINDER  /  SOFTWARE ENGINEERING</a:t>
+              <a:rPr dirty="0"/>
+              <a:t>PATHFINDER </a:t>
             </a:r>
           </a:p>
         </p:txBody>
@@ -3294,6 +3298,7 @@
           <a:lstStyle/>
           <a:p>
             <a:pPr algn="ctr"/>
+            <a:endParaRPr/>
           </a:p>
         </p:txBody>
       </p:sp>
@@ -3417,6 +3422,7 @@
           <a:lstStyle/>
           <a:p>
             <a:pPr algn="ctr"/>
+            <a:endParaRPr/>
           </a:p>
         </p:txBody>
       </p:sp>
@@ -3501,6 +3507,7 @@
           <a:lstStyle/>
           <a:p>
             <a:pPr algn="ctr"/>
+            <a:endParaRPr/>
           </a:p>
         </p:txBody>
       </p:sp>
@@ -3585,6 +3592,7 @@
           <a:lstStyle/>
           <a:p>
             <a:pPr algn="ctr"/>
+            <a:endParaRPr/>
           </a:p>
         </p:txBody>
       </p:sp>
@@ -3669,6 +3677,7 @@
           <a:lstStyle/>
           <a:p>
             <a:pPr algn="ctr"/>
+            <a:endParaRPr/>
           </a:p>
         </p:txBody>
       </p:sp>
@@ -3753,6 +3762,7 @@
           <a:lstStyle/>
           <a:p>
             <a:pPr algn="ctr"/>
+            <a:endParaRPr/>
           </a:p>
         </p:txBody>
       </p:sp>
@@ -3798,6 +3808,7 @@
           <a:lstStyle/>
           <a:p>
             <a:pPr algn="ctr"/>
+            <a:endParaRPr/>
           </a:p>
         </p:txBody>
       </p:sp>
@@ -3953,6 +3964,7 @@
           <a:lstStyle/>
           <a:p>
             <a:pPr algn="ctr"/>
+            <a:endParaRPr/>
           </a:p>
         </p:txBody>
       </p:sp>
@@ -3998,6 +4010,7 @@
           <a:lstStyle/>
           <a:p>
             <a:pPr algn="ctr"/>
+            <a:endParaRPr/>
           </a:p>
         </p:txBody>
       </p:sp>
@@ -4153,6 +4166,7 @@
           <a:lstStyle/>
           <a:p>
             <a:pPr algn="ctr"/>
+            <a:endParaRPr/>
           </a:p>
         </p:txBody>
       </p:sp>
@@ -4198,6 +4212,7 @@
           <a:lstStyle/>
           <a:p>
             <a:pPr algn="ctr"/>
+            <a:endParaRPr/>
           </a:p>
         </p:txBody>
       </p:sp>
@@ -4353,6 +4368,7 @@
           <a:lstStyle/>
           <a:p>
             <a:pPr algn="ctr"/>
+            <a:endParaRPr/>
           </a:p>
         </p:txBody>
       </p:sp>
@@ -4398,6 +4414,7 @@
           <a:lstStyle/>
           <a:p>
             <a:pPr algn="ctr"/>
+            <a:endParaRPr/>
           </a:p>
         </p:txBody>
       </p:sp>
@@ -4649,6 +4666,7 @@
           <a:lstStyle/>
           <a:p>
             <a:pPr algn="ctr"/>
+            <a:endParaRPr/>
           </a:p>
         </p:txBody>
       </p:sp>
@@ -4778,7 +4796,7 @@
 </file>
 
 <file path=ppt/slides/slide2.xml><?xml version="1.0" encoding="utf-8"?>
-<p:sld xmlns:a="http://schemas.openxmlformats.org/drawingml/2006/main" xmlns:p="http://schemas.openxmlformats.org/presentationml/2006/main" xmlns:r="http://schemas.openxmlformats.org/officeDocument/2006/relationships">
+<p:sld xmlns:a="http://schemas.openxmlformats.org/drawingml/2006/main" xmlns:r="http://schemas.openxmlformats.org/officeDocument/2006/relationships" xmlns:p="http://schemas.openxmlformats.org/presentationml/2006/main">
   <p:cSld>
     <p:spTree>
       <p:nvGrpSpPr>
@@ -4786,7 +4804,14 @@
         <p:cNvGrpSpPr/>
         <p:nvPr/>
       </p:nvGrpSpPr>
-      <p:grpSpPr/>
+      <p:grpSpPr>
+        <a:xfrm>
+          <a:off x="0" y="0"/>
+          <a:ext cx="0" cy="0"/>
+          <a:chOff x="0" y="0"/>
+          <a:chExt cx="0" cy="0"/>
+        </a:xfrm>
+      </p:grpSpPr>
       <p:sp>
         <p:nvSpPr>
           <p:cNvPr id="2" name="Rectangle 1"/>
@@ -4829,6 +4854,7 @@
           <a:lstStyle/>
           <a:p>
             <a:pPr algn="ctr"/>
+            <a:endParaRPr/>
           </a:p>
         </p:txBody>
       </p:sp>
@@ -4841,7 +4867,7 @@
         <p:spPr>
           <a:xfrm>
             <a:off x="566928" y="274320"/>
-            <a:ext cx="8229600" cy="274320"/>
+            <a:ext cx="8229600" cy="229294"/>
           </a:xfrm>
           <a:prstGeom prst="rect">
             <a:avLst/>
@@ -4866,7 +4892,8 @@
               </a:defRPr>
             </a:pPr>
             <a:r>
-              <a:t>PATHFINDER  /  SOFTWARE ENGINEERING</a:t>
+              <a:rPr dirty="0"/>
+              <a:t>PATHFINDER</a:t>
             </a:r>
           </a:p>
         </p:txBody>
@@ -4981,6 +5008,7 @@
           <a:lstStyle/>
           <a:p>
             <a:pPr algn="ctr"/>
+            <a:endParaRPr/>
           </a:p>
         </p:txBody>
       </p:sp>
@@ -5104,6 +5132,7 @@
           <a:lstStyle/>
           <a:p>
             <a:pPr algn="ctr"/>
+            <a:endParaRPr/>
           </a:p>
         </p:txBody>
       </p:sp>
@@ -5130,79 +5159,127 @@
           <a:lstStyle/>
           <a:p>
             <a:r>
-              <a:rPr sz="1400"/>
+              <a:rPr sz="1400" dirty="0"/>
               <a:t>pathfinder/</a:t>
             </a:r>
           </a:p>
           <a:p>
             <a:r>
-              <a:rPr sz="1400"/>
+              <a:rPr sz="1400" dirty="0"/>
               <a:t>├── frontend/UI/              presentation tier (browser UI)</a:t>
             </a:r>
           </a:p>
           <a:p>
             <a:r>
-              <a:rPr sz="1400"/>
+              <a:rPr sz="1400" dirty="0"/>
               <a:t>└── backend/</a:t>
             </a:r>
           </a:p>
           <a:p>
             <a:r>
-              <a:rPr sz="1400"/>
-              <a:t>    ├── app.js                 Express entry point</a:t>
-            </a:r>
-          </a:p>
-          <a:p>
-            <a:r>
-              <a:rPr sz="1400"/>
-              <a:t>    ├── routes/students.js</a:t>
-            </a:r>
-          </a:p>
-          <a:p>
-            <a:r>
-              <a:rPr sz="1400"/>
-              <a:t>    ├── controllers/studentController.js</a:t>
-            </a:r>
-          </a:p>
-          <a:p>
-            <a:r>
-              <a:rPr sz="1400"/>
-              <a:t>    ├── services/studentService.js</a:t>
-            </a:r>
-          </a:p>
-          <a:p>
-            <a:r>
-              <a:rPr sz="1400"/>
-              <a:t>    ├── repositories/studentRepository.js</a:t>
-            </a:r>
-          </a:p>
-          <a:p>
-            <a:r>
-              <a:rPr sz="1400"/>
-              <a:t>    ├── data/demoData.js</a:t>
-            </a:r>
-          </a:p>
-          <a:p>
-            <a:r>
-              <a:rPr sz="1400"/>
-              <a:t>    ├── package.json</a:t>
-            </a:r>
-          </a:p>
-          <a:p>
-            <a:r>
-              <a:rPr sz="1400"/>
-              <a:t>    └── package-lock.json</a:t>
-            </a:r>
-          </a:p>
-          <a:p>
-            <a:r>
-              <a:rPr sz="1400"/>
-              <a:t>tests/backend.test.js</a:t>
-            </a:r>
-          </a:p>
-          <a:p>
-            <a:r>
-              <a:rPr sz="1400"/>
+              <a:rPr sz="1400" dirty="0"/>
+              <a:t>    ├── </a:t>
+            </a:r>
+            <a:r>
+              <a:rPr sz="1400" dirty="0" err="1"/>
+              <a:t>app.js</a:t>
+            </a:r>
+            <a:r>
+              <a:rPr sz="1400" dirty="0"/>
+              <a:t>                 Express entry point</a:t>
+            </a:r>
+          </a:p>
+          <a:p>
+            <a:r>
+              <a:rPr sz="1400" dirty="0"/>
+              <a:t>    ├── routes/</a:t>
+            </a:r>
+            <a:r>
+              <a:rPr sz="1400" dirty="0" err="1"/>
+              <a:t>students.js</a:t>
+            </a:r>
+            <a:endParaRPr sz="1400" dirty="0"/>
+          </a:p>
+          <a:p>
+            <a:r>
+              <a:rPr sz="1400" dirty="0"/>
+              <a:t>    ├── controllers/</a:t>
+            </a:r>
+            <a:r>
+              <a:rPr sz="1400" dirty="0" err="1"/>
+              <a:t>studentController.js</a:t>
+            </a:r>
+            <a:endParaRPr sz="1400" dirty="0"/>
+          </a:p>
+          <a:p>
+            <a:r>
+              <a:rPr sz="1400" dirty="0"/>
+              <a:t>    ├── services/</a:t>
+            </a:r>
+            <a:r>
+              <a:rPr sz="1400" dirty="0" err="1"/>
+              <a:t>studentService.js</a:t>
+            </a:r>
+            <a:endParaRPr sz="1400" dirty="0"/>
+          </a:p>
+          <a:p>
+            <a:r>
+              <a:rPr sz="1400" dirty="0"/>
+              <a:t>    ├── repositories/</a:t>
+            </a:r>
+            <a:r>
+              <a:rPr sz="1400" dirty="0" err="1"/>
+              <a:t>studentRepository.js</a:t>
+            </a:r>
+            <a:endParaRPr sz="1400" dirty="0"/>
+          </a:p>
+          <a:p>
+            <a:r>
+              <a:rPr sz="1400" dirty="0"/>
+              <a:t>    ├── data/</a:t>
+            </a:r>
+            <a:r>
+              <a:rPr sz="1400" dirty="0" err="1"/>
+              <a:t>demoData.js</a:t>
+            </a:r>
+            <a:endParaRPr sz="1400" dirty="0"/>
+          </a:p>
+          <a:p>
+            <a:r>
+              <a:rPr sz="1400" dirty="0"/>
+              <a:t>    ├── </a:t>
+            </a:r>
+            <a:r>
+              <a:rPr sz="1400" dirty="0" err="1"/>
+              <a:t>package.json</a:t>
+            </a:r>
+            <a:endParaRPr sz="1400" dirty="0"/>
+          </a:p>
+          <a:p>
+            <a:r>
+              <a:rPr sz="1400" dirty="0"/>
+              <a:t>    └── package-</a:t>
+            </a:r>
+            <a:r>
+              <a:rPr sz="1400" dirty="0" err="1"/>
+              <a:t>lock.json</a:t>
+            </a:r>
+            <a:endParaRPr sz="1400" dirty="0"/>
+          </a:p>
+          <a:p>
+            <a:r>
+              <a:rPr sz="1400" dirty="0"/>
+              <a:t>tests/</a:t>
+            </a:r>
+            <a:r>
+              <a:rPr sz="1400" dirty="0" err="1"/>
+              <a:t>backend.test.js</a:t>
+            </a:r>
+            <a:endParaRPr sz="1400" dirty="0"/>
+          </a:p>
+          <a:p>
+            <a:r>
+              <a:rPr sz="1400" dirty="0"/>
               <a:t>docs/diagrams/assignment-05-class-diagram.md</a:t>
             </a:r>
           </a:p>
@@ -5250,6 +5327,7 @@
           <a:lstStyle/>
           <a:p>
             <a:pPr algn="ctr"/>
+            <a:endParaRPr/>
           </a:p>
         </p:txBody>
       </p:sp>
@@ -5373,6 +5451,7 @@
           <a:lstStyle/>
           <a:p>
             <a:pPr algn="ctr"/>
+            <a:endParaRPr/>
           </a:p>
         </p:txBody>
       </p:sp>
@@ -5496,6 +5575,7 @@
           <a:lstStyle/>
           <a:p>
             <a:pPr algn="ctr"/>
+            <a:endParaRPr/>
           </a:p>
         </p:txBody>
       </p:sp>
@@ -5619,6 +5699,7 @@
           <a:lstStyle/>
           <a:p>
             <a:pPr algn="ctr"/>
+            <a:endParaRPr/>
           </a:p>
         </p:txBody>
       </p:sp>
@@ -5717,7 +5798,7 @@
           <a:noFill/>
         </p:spPr>
         <p:txBody>
-          <a:bodyPr wrap="none" lIns="0" rIns="0" tIns="0" bIns="0">
+          <a:bodyPr wrap="none" lIns="0" tIns="0" rIns="0" bIns="0">
             <a:spAutoFit/>
           </a:bodyPr>
           <a:lstStyle/>
@@ -5745,7 +5826,7 @@
 </file>
 
 <file path=ppt/slides/slide3.xml><?xml version="1.0" encoding="utf-8"?>
-<p:sld xmlns:a="http://schemas.openxmlformats.org/drawingml/2006/main" xmlns:p="http://schemas.openxmlformats.org/presentationml/2006/main" xmlns:r="http://schemas.openxmlformats.org/officeDocument/2006/relationships">
+<p:sld xmlns:a="http://schemas.openxmlformats.org/drawingml/2006/main" xmlns:r="http://schemas.openxmlformats.org/officeDocument/2006/relationships" xmlns:p="http://schemas.openxmlformats.org/presentationml/2006/main">
   <p:cSld>
     <p:spTree>
       <p:nvGrpSpPr>
@@ -5753,7 +5834,14 @@
         <p:cNvGrpSpPr/>
         <p:nvPr/>
       </p:nvGrpSpPr>
-      <p:grpSpPr/>
+      <p:grpSpPr>
+        <a:xfrm>
+          <a:off x="0" y="0"/>
+          <a:ext cx="0" cy="0"/>
+          <a:chOff x="0" y="0"/>
+          <a:chExt cx="0" cy="0"/>
+        </a:xfrm>
+      </p:grpSpPr>
       <p:sp>
         <p:nvSpPr>
           <p:cNvPr id="2" name="Rectangle 1"/>
@@ -5796,6 +5884,7 @@
           <a:lstStyle/>
           <a:p>
             <a:pPr algn="ctr"/>
+            <a:endParaRPr/>
           </a:p>
         </p:txBody>
       </p:sp>
@@ -5808,7 +5897,7 @@
         <p:spPr>
           <a:xfrm>
             <a:off x="566928" y="274320"/>
-            <a:ext cx="8229600" cy="274320"/>
+            <a:ext cx="8229600" cy="229294"/>
           </a:xfrm>
           <a:prstGeom prst="rect">
             <a:avLst/>
@@ -5833,7 +5922,8 @@
               </a:defRPr>
             </a:pPr>
             <a:r>
-              <a:t>PATHFINDER  /  SOFTWARE ENGINEERING</a:t>
+              <a:rPr dirty="0"/>
+              <a:t>PATHFINDER</a:t>
             </a:r>
           </a:p>
         </p:txBody>
@@ -5958,6 +6048,7 @@
           <a:lstStyle/>
           <a:p>
             <a:pPr algn="ctr"/>
+            <a:endParaRPr/>
           </a:p>
         </p:txBody>
       </p:sp>
@@ -6081,6 +6172,7 @@
           <a:lstStyle/>
           <a:p>
             <a:pPr algn="ctr"/>
+            <a:endParaRPr/>
           </a:p>
         </p:txBody>
       </p:sp>
@@ -6283,6 +6375,7 @@
           <a:lstStyle/>
           <a:p>
             <a:pPr algn="ctr"/>
+            <a:endParaRPr/>
           </a:p>
         </p:txBody>
       </p:sp>
@@ -6486,6 +6579,7 @@
           <a:lstStyle/>
           <a:p>
             <a:pPr algn="ctr"/>
+            <a:endParaRPr/>
           </a:p>
         </p:txBody>
       </p:sp>
@@ -6704,7 +6798,7 @@
           <a:noFill/>
         </p:spPr>
         <p:txBody>
-          <a:bodyPr wrap="none" lIns="0" rIns="0" tIns="0" bIns="0">
+          <a:bodyPr wrap="none" lIns="0" tIns="0" rIns="0" bIns="0">
             <a:spAutoFit/>
           </a:bodyPr>
           <a:lstStyle/>
@@ -6718,6 +6812,7 @@
               </a:defRPr>
             </a:pPr>
             <a:r>
+              <a:rPr dirty="0"/>
               <a:t>FR-4 HAL AI Chatbot — PLANNED: chat UI → chat controller/service → academic context + external AI API</a:t>
             </a:r>
           </a:p>

</xml_diff>